<commit_message>
Back to top button
* Shown if  pageYOffset > 500
* v1.7.0
</commit_message>
<xml_diff>
--- a/media/components.pptx
+++ b/media/components.pptx
@@ -197,7 +197,7 @@
           <a:p>
             <a:fld id="{2493DBFB-1373-FB44-B528-39E7BE5C2A0C}" type="datetimeFigureOut">
               <a:rPr lang="sv-SE" smtClean="0"/>
-              <a:t>2019-08-30</a:t>
+              <a:t>2020-12-09</a:t>
             </a:fld>
             <a:endParaRPr lang="sv-SE"/>
           </a:p>
@@ -595,7 +595,7 @@
           <a:p>
             <a:fld id="{0199F140-DCCC-1C43-B697-AE5A4988A779}" type="datetimeFigureOut">
               <a:rPr lang="sv-SE" smtClean="0"/>
-              <a:t>2019-08-30</a:t>
+              <a:t>2020-12-09</a:t>
             </a:fld>
             <a:endParaRPr lang="sv-SE"/>
           </a:p>
@@ -765,7 +765,7 @@
           <a:p>
             <a:fld id="{0199F140-DCCC-1C43-B697-AE5A4988A779}" type="datetimeFigureOut">
               <a:rPr lang="sv-SE" smtClean="0"/>
-              <a:t>2019-08-30</a:t>
+              <a:t>2020-12-09</a:t>
             </a:fld>
             <a:endParaRPr lang="sv-SE"/>
           </a:p>
@@ -945,7 +945,7 @@
           <a:p>
             <a:fld id="{0199F140-DCCC-1C43-B697-AE5A4988A779}" type="datetimeFigureOut">
               <a:rPr lang="sv-SE" smtClean="0"/>
-              <a:t>2019-08-30</a:t>
+              <a:t>2020-12-09</a:t>
             </a:fld>
             <a:endParaRPr lang="sv-SE"/>
           </a:p>
@@ -1115,7 +1115,7 @@
           <a:p>
             <a:fld id="{0199F140-DCCC-1C43-B697-AE5A4988A779}" type="datetimeFigureOut">
               <a:rPr lang="sv-SE" smtClean="0"/>
-              <a:t>2019-08-30</a:t>
+              <a:t>2020-12-09</a:t>
             </a:fld>
             <a:endParaRPr lang="sv-SE"/>
           </a:p>
@@ -1359,7 +1359,7 @@
           <a:p>
             <a:fld id="{0199F140-DCCC-1C43-B697-AE5A4988A779}" type="datetimeFigureOut">
               <a:rPr lang="sv-SE" smtClean="0"/>
-              <a:t>2019-08-30</a:t>
+              <a:t>2020-12-09</a:t>
             </a:fld>
             <a:endParaRPr lang="sv-SE"/>
           </a:p>
@@ -1591,7 +1591,7 @@
           <a:p>
             <a:fld id="{0199F140-DCCC-1C43-B697-AE5A4988A779}" type="datetimeFigureOut">
               <a:rPr lang="sv-SE" smtClean="0"/>
-              <a:t>2019-08-30</a:t>
+              <a:t>2020-12-09</a:t>
             </a:fld>
             <a:endParaRPr lang="sv-SE"/>
           </a:p>
@@ -1958,7 +1958,7 @@
           <a:p>
             <a:fld id="{0199F140-DCCC-1C43-B697-AE5A4988A779}" type="datetimeFigureOut">
               <a:rPr lang="sv-SE" smtClean="0"/>
-              <a:t>2019-08-30</a:t>
+              <a:t>2020-12-09</a:t>
             </a:fld>
             <a:endParaRPr lang="sv-SE"/>
           </a:p>
@@ -2076,7 +2076,7 @@
           <a:p>
             <a:fld id="{0199F140-DCCC-1C43-B697-AE5A4988A779}" type="datetimeFigureOut">
               <a:rPr lang="sv-SE" smtClean="0"/>
-              <a:t>2019-08-30</a:t>
+              <a:t>2020-12-09</a:t>
             </a:fld>
             <a:endParaRPr lang="sv-SE"/>
           </a:p>
@@ -2171,7 +2171,7 @@
           <a:p>
             <a:fld id="{0199F140-DCCC-1C43-B697-AE5A4988A779}" type="datetimeFigureOut">
               <a:rPr lang="sv-SE" smtClean="0"/>
-              <a:t>2019-08-30</a:t>
+              <a:t>2020-12-09</a:t>
             </a:fld>
             <a:endParaRPr lang="sv-SE"/>
           </a:p>
@@ -2448,7 +2448,7 @@
           <a:p>
             <a:fld id="{0199F140-DCCC-1C43-B697-AE5A4988A779}" type="datetimeFigureOut">
               <a:rPr lang="sv-SE" smtClean="0"/>
-              <a:t>2019-08-30</a:t>
+              <a:t>2020-12-09</a:t>
             </a:fld>
             <a:endParaRPr lang="sv-SE"/>
           </a:p>
@@ -2705,7 +2705,7 @@
           <a:p>
             <a:fld id="{0199F140-DCCC-1C43-B697-AE5A4988A779}" type="datetimeFigureOut">
               <a:rPr lang="sv-SE" smtClean="0"/>
-              <a:t>2019-08-30</a:t>
+              <a:t>2020-12-09</a:t>
             </a:fld>
             <a:endParaRPr lang="sv-SE"/>
           </a:p>
@@ -2918,7 +2918,7 @@
           <a:p>
             <a:fld id="{0199F140-DCCC-1C43-B697-AE5A4988A779}" type="datetimeFigureOut">
               <a:rPr lang="sv-SE" smtClean="0"/>
-              <a:t>2019-08-30</a:t>
+              <a:t>2020-12-09</a:t>
             </a:fld>
             <a:endParaRPr lang="sv-SE"/>
           </a:p>
@@ -4849,6 +4849,95 @@
                 <a:srgbClr val="00B0F0"/>
               </a:solidFill>
             </a:endParaRPr>
+          </a:p>
+        </p:txBody>
+      </p:sp>
+      <p:pic>
+        <p:nvPicPr>
+          <p:cNvPr id="4" name="Bildobjekt 3">
+            <a:extLst>
+              <a:ext uri="{FF2B5EF4-FFF2-40B4-BE49-F238E27FC236}">
+                <a16:creationId xmlns:a16="http://schemas.microsoft.com/office/drawing/2014/main" id="{AB4847C6-44D4-3141-A8C5-845AF6702EF8}"/>
+              </a:ext>
+            </a:extLst>
+          </p:cNvPr>
+          <p:cNvPicPr>
+            <a:picLocks noChangeAspect="1"/>
+          </p:cNvPicPr>
+          <p:nvPr/>
+        </p:nvPicPr>
+        <p:blipFill>
+          <a:blip r:embed="rId4"/>
+          <a:stretch>
+            <a:fillRect/>
+          </a:stretch>
+        </p:blipFill>
+        <p:spPr>
+          <a:xfrm>
+            <a:off x="13990637" y="10556046"/>
+            <a:ext cx="1041400" cy="406400"/>
+          </a:xfrm>
+          <a:prstGeom prst="rect">
+            <a:avLst/>
+          </a:prstGeom>
+        </p:spPr>
+      </p:pic>
+      <p:sp>
+        <p:nvSpPr>
+          <p:cNvPr id="39" name="Rektangel 38">
+            <a:extLst>
+              <a:ext uri="{FF2B5EF4-FFF2-40B4-BE49-F238E27FC236}">
+                <a16:creationId xmlns:a16="http://schemas.microsoft.com/office/drawing/2014/main" id="{17233EC3-2974-0E4C-B031-BBE3D83BD79A}"/>
+              </a:ext>
+            </a:extLst>
+          </p:cNvPr>
+          <p:cNvSpPr/>
+          <p:nvPr/>
+        </p:nvSpPr>
+        <p:spPr>
+          <a:xfrm>
+            <a:off x="12898877" y="10182505"/>
+            <a:ext cx="2133160" cy="814803"/>
+          </a:xfrm>
+          <a:prstGeom prst="rect">
+            <a:avLst/>
+          </a:prstGeom>
+          <a:noFill/>
+          <a:ln w="28575">
+            <a:solidFill>
+              <a:srgbClr val="FF0000"/>
+            </a:solidFill>
+          </a:ln>
+        </p:spPr>
+        <p:style>
+          <a:lnRef idx="2">
+            <a:schemeClr val="accent1">
+              <a:shade val="50000"/>
+            </a:schemeClr>
+          </a:lnRef>
+          <a:fillRef idx="1">
+            <a:schemeClr val="accent1"/>
+          </a:fillRef>
+          <a:effectRef idx="0">
+            <a:schemeClr val="accent1"/>
+          </a:effectRef>
+          <a:fontRef idx="minor">
+            <a:schemeClr val="lt1"/>
+          </a:fontRef>
+        </p:style>
+        <p:txBody>
+          <a:bodyPr rtlCol="0" anchor="ctr"/>
+          <a:lstStyle/>
+          <a:p>
+            <a:pPr algn="ctr"/>
+            <a:r>
+              <a:rPr lang="sv-SE"/>
+              <a:t>LuToTop</a:t>
+            </a:r>
+          </a:p>
+          <a:p>
+            <a:pPr algn="ctr"/>
+            <a:endParaRPr lang="sv-SE"/>
           </a:p>
         </p:txBody>
       </p:sp>

</xml_diff>

<commit_message>
v5.0.0 new component image for readme, autocomplete for header search field
</commit_message>
<xml_diff>
--- a/media/components.pptx
+++ b/media/components.pptx
@@ -197,7 +197,7 @@
           <a:p>
             <a:fld id="{2493DBFB-1373-FB44-B528-39E7BE5C2A0C}" type="datetimeFigureOut">
               <a:rPr lang="sv-SE" smtClean="0"/>
-              <a:t>2021-11-30</a:t>
+              <a:t>2026-08-28</a:t>
             </a:fld>
             <a:endParaRPr lang="sv-SE"/>
           </a:p>
@@ -595,7 +595,7 @@
           <a:p>
             <a:fld id="{0199F140-DCCC-1C43-B697-AE5A4988A779}" type="datetimeFigureOut">
               <a:rPr lang="sv-SE" smtClean="0"/>
-              <a:t>2021-11-30</a:t>
+              <a:t>2026-08-28</a:t>
             </a:fld>
             <a:endParaRPr lang="sv-SE"/>
           </a:p>
@@ -765,7 +765,7 @@
           <a:p>
             <a:fld id="{0199F140-DCCC-1C43-B697-AE5A4988A779}" type="datetimeFigureOut">
               <a:rPr lang="sv-SE" smtClean="0"/>
-              <a:t>2021-11-30</a:t>
+              <a:t>2026-08-28</a:t>
             </a:fld>
             <a:endParaRPr lang="sv-SE"/>
           </a:p>
@@ -945,7 +945,7 @@
           <a:p>
             <a:fld id="{0199F140-DCCC-1C43-B697-AE5A4988A779}" type="datetimeFigureOut">
               <a:rPr lang="sv-SE" smtClean="0"/>
-              <a:t>2021-11-30</a:t>
+              <a:t>2026-08-28</a:t>
             </a:fld>
             <a:endParaRPr lang="sv-SE"/>
           </a:p>
@@ -1115,7 +1115,7 @@
           <a:p>
             <a:fld id="{0199F140-DCCC-1C43-B697-AE5A4988A779}" type="datetimeFigureOut">
               <a:rPr lang="sv-SE" smtClean="0"/>
-              <a:t>2021-11-30</a:t>
+              <a:t>2026-08-28</a:t>
             </a:fld>
             <a:endParaRPr lang="sv-SE"/>
           </a:p>
@@ -1359,7 +1359,7 @@
           <a:p>
             <a:fld id="{0199F140-DCCC-1C43-B697-AE5A4988A779}" type="datetimeFigureOut">
               <a:rPr lang="sv-SE" smtClean="0"/>
-              <a:t>2021-11-30</a:t>
+              <a:t>2026-08-28</a:t>
             </a:fld>
             <a:endParaRPr lang="sv-SE"/>
           </a:p>
@@ -1591,7 +1591,7 @@
           <a:p>
             <a:fld id="{0199F140-DCCC-1C43-B697-AE5A4988A779}" type="datetimeFigureOut">
               <a:rPr lang="sv-SE" smtClean="0"/>
-              <a:t>2021-11-30</a:t>
+              <a:t>2026-08-28</a:t>
             </a:fld>
             <a:endParaRPr lang="sv-SE"/>
           </a:p>
@@ -1958,7 +1958,7 @@
           <a:p>
             <a:fld id="{0199F140-DCCC-1C43-B697-AE5A4988A779}" type="datetimeFigureOut">
               <a:rPr lang="sv-SE" smtClean="0"/>
-              <a:t>2021-11-30</a:t>
+              <a:t>2026-08-28</a:t>
             </a:fld>
             <a:endParaRPr lang="sv-SE"/>
           </a:p>
@@ -2076,7 +2076,7 @@
           <a:p>
             <a:fld id="{0199F140-DCCC-1C43-B697-AE5A4988A779}" type="datetimeFigureOut">
               <a:rPr lang="sv-SE" smtClean="0"/>
-              <a:t>2021-11-30</a:t>
+              <a:t>2026-08-28</a:t>
             </a:fld>
             <a:endParaRPr lang="sv-SE"/>
           </a:p>
@@ -2171,7 +2171,7 @@
           <a:p>
             <a:fld id="{0199F140-DCCC-1C43-B697-AE5A4988A779}" type="datetimeFigureOut">
               <a:rPr lang="sv-SE" smtClean="0"/>
-              <a:t>2021-11-30</a:t>
+              <a:t>2026-08-28</a:t>
             </a:fld>
             <a:endParaRPr lang="sv-SE"/>
           </a:p>
@@ -2448,7 +2448,7 @@
           <a:p>
             <a:fld id="{0199F140-DCCC-1C43-B697-AE5A4988A779}" type="datetimeFigureOut">
               <a:rPr lang="sv-SE" smtClean="0"/>
-              <a:t>2021-11-30</a:t>
+              <a:t>2026-08-28</a:t>
             </a:fld>
             <a:endParaRPr lang="sv-SE"/>
           </a:p>
@@ -2705,7 +2705,7 @@
           <a:p>
             <a:fld id="{0199F140-DCCC-1C43-B697-AE5A4988A779}" type="datetimeFigureOut">
               <a:rPr lang="sv-SE" smtClean="0"/>
-              <a:t>2021-11-30</a:t>
+              <a:t>2026-08-28</a:t>
             </a:fld>
             <a:endParaRPr lang="sv-SE"/>
           </a:p>
@@ -2918,7 +2918,7 @@
           <a:p>
             <a:fld id="{0199F140-DCCC-1C43-B697-AE5A4988A779}" type="datetimeFigureOut">
               <a:rPr lang="sv-SE" smtClean="0"/>
-              <a:t>2021-11-30</a:t>
+              <a:t>2026-08-28</a:t>
             </a:fld>
             <a:endParaRPr lang="sv-SE"/>
           </a:p>
@@ -3325,10 +3325,10 @@
       </p:grpSpPr>
       <p:pic>
         <p:nvPicPr>
-          <p:cNvPr id="5" name="Bildobjekt 4">
+          <p:cNvPr id="6" name="Bildobjekt 5">
             <a:extLst>
               <a:ext uri="{FF2B5EF4-FFF2-40B4-BE49-F238E27FC236}">
-                <a16:creationId xmlns:a16="http://schemas.microsoft.com/office/drawing/2014/main" id="{0A4C3049-568B-AB48-B766-13A547C4E355}"/>
+                <a16:creationId xmlns:a16="http://schemas.microsoft.com/office/drawing/2014/main" id="{7D041A8C-0D0B-A3FE-7187-F8E7F976AF02}"/>
               </a:ext>
             </a:extLst>
           </p:cNvPr>
@@ -3345,8 +3345,8 @@
         </p:blipFill>
         <p:spPr>
           <a:xfrm>
-            <a:off x="808037" y="712932"/>
-            <a:ext cx="14224000" cy="11201400"/>
+            <a:off x="54374" y="575657"/>
+            <a:ext cx="15728296" cy="10299371"/>
           </a:xfrm>
           <a:prstGeom prst="rect">
             <a:avLst/>
@@ -3367,8 +3367,8 @@
         </p:nvSpPr>
         <p:spPr>
           <a:xfrm>
-            <a:off x="808037" y="703559"/>
-            <a:ext cx="14224000" cy="2647666"/>
+            <a:off x="57406" y="575657"/>
+            <a:ext cx="15708166" cy="2775568"/>
           </a:xfrm>
           <a:prstGeom prst="rect">
             <a:avLst/>
@@ -3420,7 +3420,7 @@
         <p:spPr>
           <a:xfrm>
             <a:off x="6772111" y="2237717"/>
-            <a:ext cx="1651379" cy="369332"/>
+            <a:ext cx="1651379" cy="461665"/>
           </a:xfrm>
           <a:prstGeom prst="rect">
             <a:avLst/>
@@ -3434,14 +3434,14 @@
           <a:lstStyle/>
           <a:p>
             <a:r>
-              <a:rPr lang="sv-SE" dirty="0" err="1">
+              <a:rPr lang="sv-SE" sz="2400" dirty="0" err="1">
                 <a:solidFill>
                   <a:srgbClr val="FF0000"/>
                 </a:solidFill>
               </a:rPr>
               <a:t>LuHeader</a:t>
             </a:r>
-            <a:endParaRPr lang="sv-SE" dirty="0">
+            <a:endParaRPr lang="sv-SE" sz="2400" dirty="0">
               <a:solidFill>
                 <a:srgbClr val="FF0000"/>
               </a:solidFill>
@@ -3463,8 +3463,8 @@
         </p:nvSpPr>
         <p:spPr>
           <a:xfrm>
-            <a:off x="808037" y="3423933"/>
-            <a:ext cx="14224000" cy="475398"/>
+            <a:off x="89402" y="3423933"/>
+            <a:ext cx="15676169" cy="422365"/>
           </a:xfrm>
           <a:prstGeom prst="rect">
             <a:avLst/>
@@ -3559,8 +3559,8 @@
         </p:nvSpPr>
         <p:spPr>
           <a:xfrm>
-            <a:off x="5765516" y="3944149"/>
-            <a:ext cx="1651379" cy="369332"/>
+            <a:off x="9858407" y="9700559"/>
+            <a:ext cx="1651379" cy="461665"/>
           </a:xfrm>
           <a:prstGeom prst="rect">
             <a:avLst/>
@@ -3574,14 +3574,14 @@
           <a:lstStyle/>
           <a:p>
             <a:r>
-              <a:rPr lang="sv-SE" dirty="0" err="1">
+              <a:rPr lang="sv-SE" sz="2400" dirty="0" err="1">
                 <a:solidFill>
                   <a:srgbClr val="FF0000"/>
                 </a:solidFill>
               </a:rPr>
               <a:t>LuMain</a:t>
             </a:r>
-            <a:endParaRPr lang="sv-SE" dirty="0">
+            <a:endParaRPr lang="sv-SE" sz="2400" dirty="0">
               <a:solidFill>
                 <a:srgbClr val="FF0000"/>
               </a:solidFill>
@@ -3603,8 +3603,8 @@
         </p:nvSpPr>
         <p:spPr>
           <a:xfrm>
-            <a:off x="808037" y="3952364"/>
-            <a:ext cx="14224000" cy="4898114"/>
+            <a:off x="74502" y="3899331"/>
+            <a:ext cx="15728297" cy="6881266"/>
           </a:xfrm>
           <a:prstGeom prst="rect">
             <a:avLst/>
@@ -3643,10 +3643,10 @@
       </p:sp>
       <p:sp>
         <p:nvSpPr>
-          <p:cNvPr id="14" name="Rektangel 13">
+          <p:cNvPr id="20" name="Rektangel 19">
             <a:extLst>
               <a:ext uri="{FF2B5EF4-FFF2-40B4-BE49-F238E27FC236}">
-                <a16:creationId xmlns:a16="http://schemas.microsoft.com/office/drawing/2014/main" id="{B7CD40B7-8366-E147-9A29-51FCA3F872A1}"/>
+                <a16:creationId xmlns:a16="http://schemas.microsoft.com/office/drawing/2014/main" id="{C4096923-47E1-034B-AC56-7CD1C2004894}"/>
               </a:ext>
             </a:extLst>
           </p:cNvPr>
@@ -3655,8 +3655,8 @@
         </p:nvSpPr>
         <p:spPr>
           <a:xfrm>
-            <a:off x="808037" y="9033211"/>
-            <a:ext cx="14224000" cy="2871748"/>
+            <a:off x="11292555" y="2303618"/>
+            <a:ext cx="4241094" cy="814803"/>
           </a:xfrm>
           <a:prstGeom prst="rect">
             <a:avLst/>
@@ -3664,7 +3664,7 @@
           <a:noFill/>
           <a:ln w="28575">
             <a:solidFill>
-              <a:srgbClr val="FF0000"/>
+              <a:schemeClr val="accent1"/>
             </a:solidFill>
           </a:ln>
         </p:spPr>
@@ -3689,16 +3689,20 @@
           <a:lstStyle/>
           <a:p>
             <a:pPr algn="ctr"/>
-            <a:endParaRPr lang="sv-SE"/>
-          </a:p>
-        </p:txBody>
-      </p:sp>
-      <p:sp>
-        <p:nvSpPr>
-          <p:cNvPr id="15" name="textruta 14">
+            <a:endParaRPr lang="sv-SE">
+              <a:solidFill>
+                <a:srgbClr val="00B0F0"/>
+              </a:solidFill>
+            </a:endParaRPr>
+          </a:p>
+        </p:txBody>
+      </p:sp>
+      <p:sp>
+        <p:nvSpPr>
+          <p:cNvPr id="21" name="textruta 20">
             <a:extLst>
               <a:ext uri="{FF2B5EF4-FFF2-40B4-BE49-F238E27FC236}">
-                <a16:creationId xmlns:a16="http://schemas.microsoft.com/office/drawing/2014/main" id="{F5A8A7A4-F80F-5C44-AF2F-18C15F545B93}"/>
+                <a16:creationId xmlns:a16="http://schemas.microsoft.com/office/drawing/2014/main" id="{9A0EFCE9-05DC-6241-AACF-729A22334CDF}"/>
               </a:ext>
             </a:extLst>
           </p:cNvPr>
@@ -3707,8 +3711,8 @@
         </p:nvSpPr>
         <p:spPr>
           <a:xfrm>
-            <a:off x="7211113" y="9075635"/>
-            <a:ext cx="1651379" cy="369332"/>
+            <a:off x="12437829" y="2711019"/>
+            <a:ext cx="1651379" cy="646331"/>
           </a:xfrm>
           <a:prstGeom prst="rect">
             <a:avLst/>
@@ -3724,25 +3728,32 @@
             <a:r>
               <a:rPr lang="sv-SE" dirty="0" err="1">
                 <a:solidFill>
-                  <a:srgbClr val="FF0000"/>
+                  <a:schemeClr val="accent1"/>
                 </a:solidFill>
               </a:rPr>
-              <a:t>LuFooter</a:t>
+              <a:t>navbarmenu</a:t>
             </a:r>
             <a:endParaRPr lang="sv-SE" dirty="0">
               <a:solidFill>
-                <a:srgbClr val="FF0000"/>
+                <a:schemeClr val="accent1"/>
               </a:solidFill>
             </a:endParaRPr>
           </a:p>
-        </p:txBody>
-      </p:sp>
-      <p:sp>
-        <p:nvSpPr>
-          <p:cNvPr id="17" name="Rektangel 16">
+          <a:p>
+            <a:endParaRPr lang="sv-SE" dirty="0">
+              <a:solidFill>
+                <a:schemeClr val="accent1"/>
+              </a:solidFill>
+            </a:endParaRPr>
+          </a:p>
+        </p:txBody>
+      </p:sp>
+      <p:sp>
+        <p:nvSpPr>
+          <p:cNvPr id="23" name="Rektangel 22">
             <a:extLst>
               <a:ext uri="{FF2B5EF4-FFF2-40B4-BE49-F238E27FC236}">
-                <a16:creationId xmlns:a16="http://schemas.microsoft.com/office/drawing/2014/main" id="{F1CB2410-E5D1-5C43-B263-D5A9675FAF86}"/>
+                <a16:creationId xmlns:a16="http://schemas.microsoft.com/office/drawing/2014/main" id="{430190A7-4843-CD47-B35F-B0F3BBEE9BE0}"/>
               </a:ext>
             </a:extLst>
           </p:cNvPr>
@@ -3751,8 +3762,8 @@
         </p:nvSpPr>
         <p:spPr>
           <a:xfrm>
-            <a:off x="1042324" y="4188853"/>
-            <a:ext cx="3505201" cy="4074772"/>
+            <a:off x="74502" y="602191"/>
+            <a:ext cx="15581810" cy="485801"/>
           </a:xfrm>
           <a:prstGeom prst="rect">
             <a:avLst/>
@@ -3795,10 +3806,10 @@
       </p:sp>
       <p:sp>
         <p:nvSpPr>
-          <p:cNvPr id="19" name="textruta 18">
+          <p:cNvPr id="24" name="textruta 23">
             <a:extLst>
               <a:ext uri="{FF2B5EF4-FFF2-40B4-BE49-F238E27FC236}">
-                <a16:creationId xmlns:a16="http://schemas.microsoft.com/office/drawing/2014/main" id="{1A799A92-9929-284C-848F-782621BED763}"/>
+                <a16:creationId xmlns:a16="http://schemas.microsoft.com/office/drawing/2014/main" id="{02C41DA7-D958-5C47-99FC-201E8593E75F}"/>
               </a:ext>
             </a:extLst>
           </p:cNvPr>
@@ -3807,8 +3818,8 @@
         </p:nvSpPr>
         <p:spPr>
           <a:xfrm>
-            <a:off x="2420749" y="4341002"/>
-            <a:ext cx="1651379" cy="369332"/>
+            <a:off x="7280398" y="656318"/>
+            <a:ext cx="1651379" cy="646331"/>
           </a:xfrm>
           <a:prstGeom prst="rect">
             <a:avLst/>
@@ -3824,11 +3835,24 @@
             <a:r>
               <a:rPr lang="sv-SE" dirty="0" err="1">
                 <a:solidFill>
-                  <a:schemeClr val="accent1"/>
+                  <a:schemeClr val="accent1">
+                    <a:lumMod val="20000"/>
+                    <a:lumOff val="80000"/>
+                  </a:schemeClr>
                 </a:solidFill>
               </a:rPr>
-              <a:t>leftmenu</a:t>
-            </a:r>
+              <a:t>topmenu</a:t>
+            </a:r>
+            <a:endParaRPr lang="sv-SE" dirty="0">
+              <a:solidFill>
+                <a:schemeClr val="accent1">
+                  <a:lumMod val="20000"/>
+                  <a:lumOff val="80000"/>
+                </a:schemeClr>
+              </a:solidFill>
+            </a:endParaRPr>
+          </a:p>
+          <a:p>
             <a:endParaRPr lang="sv-SE" dirty="0">
               <a:solidFill>
                 <a:schemeClr val="accent1"/>
@@ -3839,10 +3863,10 @@
       </p:sp>
       <p:sp>
         <p:nvSpPr>
-          <p:cNvPr id="20" name="Rektangel 19">
+          <p:cNvPr id="29" name="Rektangel 28">
             <a:extLst>
               <a:ext uri="{FF2B5EF4-FFF2-40B4-BE49-F238E27FC236}">
-                <a16:creationId xmlns:a16="http://schemas.microsoft.com/office/drawing/2014/main" id="{C4096923-47E1-034B-AC56-7CD1C2004894}"/>
+                <a16:creationId xmlns:a16="http://schemas.microsoft.com/office/drawing/2014/main" id="{0FDDB090-A945-5246-8689-8BE882A94EEF}"/>
               </a:ext>
             </a:extLst>
           </p:cNvPr>
@@ -3851,8 +3875,8 @@
         </p:nvSpPr>
         <p:spPr>
           <a:xfrm>
-            <a:off x="11292555" y="2303618"/>
-            <a:ext cx="3505201" cy="814803"/>
+            <a:off x="473696" y="4029900"/>
+            <a:ext cx="9590864" cy="4846844"/>
           </a:xfrm>
           <a:prstGeom prst="rect">
             <a:avLst/>
@@ -3895,10 +3919,10 @@
       </p:sp>
       <p:sp>
         <p:nvSpPr>
-          <p:cNvPr id="21" name="textruta 20">
+          <p:cNvPr id="30" name="textruta 29">
             <a:extLst>
               <a:ext uri="{FF2B5EF4-FFF2-40B4-BE49-F238E27FC236}">
-                <a16:creationId xmlns:a16="http://schemas.microsoft.com/office/drawing/2014/main" id="{9A0EFCE9-05DC-6241-AACF-729A22334CDF}"/>
+                <a16:creationId xmlns:a16="http://schemas.microsoft.com/office/drawing/2014/main" id="{5CA90985-43AB-A445-8B15-F9F21B9B44F1}"/>
               </a:ext>
             </a:extLst>
           </p:cNvPr>
@@ -3907,8 +3931,8 @@
         </p:nvSpPr>
         <p:spPr>
           <a:xfrm>
-            <a:off x="12437829" y="2711019"/>
-            <a:ext cx="1651379" cy="646331"/>
+            <a:off x="6421542" y="4282396"/>
+            <a:ext cx="3276679" cy="738664"/>
           </a:xfrm>
           <a:prstGeom prst="rect">
             <a:avLst/>
@@ -3922,34 +3946,42 @@
           <a:lstStyle/>
           <a:p>
             <a:r>
-              <a:rPr lang="sv-SE" dirty="0" err="1">
+              <a:rPr lang="sv-SE" sz="2400" dirty="0">
                 <a:solidFill>
                   <a:schemeClr val="accent1"/>
                 </a:solidFill>
               </a:rPr>
-              <a:t>navbarmenu</a:t>
-            </a:r>
+              <a:t>default </a:t>
+            </a:r>
+            <a:r>
+              <a:rPr lang="sv-SE" sz="2400" dirty="0" err="1">
+                <a:solidFill>
+                  <a:schemeClr val="accent1"/>
+                </a:solidFill>
+              </a:rPr>
+              <a:t>slot</a:t>
+            </a:r>
+            <a:endParaRPr lang="sv-SE" sz="2400" dirty="0">
+              <a:solidFill>
+                <a:schemeClr val="accent1"/>
+              </a:solidFill>
+            </a:endParaRPr>
+          </a:p>
+          <a:p>
             <a:endParaRPr lang="sv-SE" dirty="0">
               <a:solidFill>
                 <a:schemeClr val="accent1"/>
               </a:solidFill>
             </a:endParaRPr>
           </a:p>
-          <a:p>
-            <a:endParaRPr lang="sv-SE" dirty="0">
-              <a:solidFill>
-                <a:schemeClr val="accent1"/>
-              </a:solidFill>
-            </a:endParaRPr>
-          </a:p>
-        </p:txBody>
-      </p:sp>
-      <p:sp>
-        <p:nvSpPr>
-          <p:cNvPr id="23" name="Rektangel 22">
+        </p:txBody>
+      </p:sp>
+      <p:sp>
+        <p:nvSpPr>
+          <p:cNvPr id="31" name="Rektangel 30">
             <a:extLst>
               <a:ext uri="{FF2B5EF4-FFF2-40B4-BE49-F238E27FC236}">
-                <a16:creationId xmlns:a16="http://schemas.microsoft.com/office/drawing/2014/main" id="{430190A7-4843-CD47-B35F-B0F3BBEE9BE0}"/>
+                <a16:creationId xmlns:a16="http://schemas.microsoft.com/office/drawing/2014/main" id="{BB6E1F10-2781-8E4E-A39B-E195870A0F40}"/>
               </a:ext>
             </a:extLst>
           </p:cNvPr>
@@ -3958,8 +3990,8 @@
         </p:nvSpPr>
         <p:spPr>
           <a:xfrm>
-            <a:off x="903573" y="758248"/>
-            <a:ext cx="14029899" cy="485801"/>
+            <a:off x="679146" y="9086967"/>
+            <a:ext cx="3212630" cy="598935"/>
           </a:xfrm>
           <a:prstGeom prst="rect">
             <a:avLst/>
@@ -4002,10 +4034,10 @@
       </p:sp>
       <p:sp>
         <p:nvSpPr>
-          <p:cNvPr id="24" name="textruta 23">
+          <p:cNvPr id="32" name="textruta 31">
             <a:extLst>
               <a:ext uri="{FF2B5EF4-FFF2-40B4-BE49-F238E27FC236}">
-                <a16:creationId xmlns:a16="http://schemas.microsoft.com/office/drawing/2014/main" id="{02C41DA7-D958-5C47-99FC-201E8593E75F}"/>
+                <a16:creationId xmlns:a16="http://schemas.microsoft.com/office/drawing/2014/main" id="{67E51921-BC36-9143-A3EB-BAAE8E188D5A}"/>
               </a:ext>
             </a:extLst>
           </p:cNvPr>
@@ -4014,8 +4046,8 @@
         </p:nvSpPr>
         <p:spPr>
           <a:xfrm>
-            <a:off x="7313852" y="736770"/>
-            <a:ext cx="1651379" cy="646331"/>
+            <a:off x="672254" y="9052592"/>
+            <a:ext cx="1557989" cy="646331"/>
           </a:xfrm>
           <a:prstGeom prst="rect">
             <a:avLst/>
@@ -4031,38 +4063,32 @@
             <a:r>
               <a:rPr lang="sv-SE" dirty="0" err="1">
                 <a:solidFill>
-                  <a:schemeClr val="accent1">
-                    <a:lumMod val="20000"/>
-                    <a:lumOff val="80000"/>
-                  </a:schemeClr>
+                  <a:schemeClr val="accent1"/>
                 </a:solidFill>
               </a:rPr>
-              <a:t>topmenu</a:t>
-            </a:r>
-            <a:endParaRPr lang="sv-SE" dirty="0">
-              <a:solidFill>
-                <a:schemeClr val="accent1">
-                  <a:lumMod val="20000"/>
-                  <a:lumOff val="80000"/>
-                </a:schemeClr>
-              </a:solidFill>
-            </a:endParaRPr>
-          </a:p>
-          <a:p>
+              <a:t>pageManager</a:t>
+            </a:r>
             <a:endParaRPr lang="sv-SE" dirty="0">
               <a:solidFill>
                 <a:schemeClr val="accent1"/>
               </a:solidFill>
             </a:endParaRPr>
           </a:p>
-        </p:txBody>
-      </p:sp>
-      <p:sp>
-        <p:nvSpPr>
-          <p:cNvPr id="25" name="Rektangel 24">
+          <a:p>
+            <a:endParaRPr lang="sv-SE" dirty="0">
+              <a:solidFill>
+                <a:schemeClr val="accent1"/>
+              </a:solidFill>
+            </a:endParaRPr>
+          </a:p>
+        </p:txBody>
+      </p:sp>
+      <p:sp>
+        <p:nvSpPr>
+          <p:cNvPr id="33" name="Rektangel 32">
             <a:extLst>
               <a:ext uri="{FF2B5EF4-FFF2-40B4-BE49-F238E27FC236}">
-                <a16:creationId xmlns:a16="http://schemas.microsoft.com/office/drawing/2014/main" id="{E8BFCB4E-B335-4B4E-B3DA-69AC4EAF6CC5}"/>
+                <a16:creationId xmlns:a16="http://schemas.microsoft.com/office/drawing/2014/main" id="{74573ADC-8E09-954C-9BFD-153A42E84E0E}"/>
               </a:ext>
             </a:extLst>
           </p:cNvPr>
@@ -4071,8 +4097,8 @@
         </p:nvSpPr>
         <p:spPr>
           <a:xfrm>
-            <a:off x="5699246" y="9627700"/>
-            <a:ext cx="3529460" cy="1283590"/>
+            <a:off x="4004096" y="9096384"/>
+            <a:ext cx="1485902" cy="598934"/>
           </a:xfrm>
           <a:prstGeom prst="rect">
             <a:avLst/>
@@ -4115,10 +4141,10 @@
       </p:sp>
       <p:sp>
         <p:nvSpPr>
-          <p:cNvPr id="26" name="textruta 25">
+          <p:cNvPr id="34" name="textruta 33">
             <a:extLst>
               <a:ext uri="{FF2B5EF4-FFF2-40B4-BE49-F238E27FC236}">
-                <a16:creationId xmlns:a16="http://schemas.microsoft.com/office/drawing/2014/main" id="{24DBA9AE-F6C8-8C45-B8B7-B5E6588D7B36}"/>
+                <a16:creationId xmlns:a16="http://schemas.microsoft.com/office/drawing/2014/main" id="{84F9CB2F-73B8-914F-BC19-CEBA68229E2B}"/>
               </a:ext>
             </a:extLst>
           </p:cNvPr>
@@ -4127,8 +4153,8 @@
         </p:nvSpPr>
         <p:spPr>
           <a:xfrm>
-            <a:off x="7920039" y="9676816"/>
-            <a:ext cx="1651379" cy="646331"/>
+            <a:off x="3973453" y="9100393"/>
+            <a:ext cx="1516544" cy="646331"/>
           </a:xfrm>
           <a:prstGeom prst="rect">
             <a:avLst/>
@@ -4147,7 +4173,7 @@
                   <a:schemeClr val="accent1"/>
                 </a:solidFill>
               </a:rPr>
-              <a:t>contact</a:t>
+              <a:t>lastUpdated</a:t>
             </a:r>
             <a:endParaRPr lang="sv-SE" dirty="0">
               <a:solidFill>
@@ -4166,10 +4192,10 @@
       </p:sp>
       <p:sp>
         <p:nvSpPr>
-          <p:cNvPr id="27" name="Rektangel 26">
+          <p:cNvPr id="35" name="Rektangel 34">
             <a:extLst>
               <a:ext uri="{FF2B5EF4-FFF2-40B4-BE49-F238E27FC236}">
-                <a16:creationId xmlns:a16="http://schemas.microsoft.com/office/drawing/2014/main" id="{9D91B7FE-F2BA-944B-A795-F00FB3936197}"/>
+                <a16:creationId xmlns:a16="http://schemas.microsoft.com/office/drawing/2014/main" id="{EAF89F60-878A-9E4D-961F-C89D1B752D86}"/>
               </a:ext>
             </a:extLst>
           </p:cNvPr>
@@ -4178,8 +4204,8 @@
         </p:nvSpPr>
         <p:spPr>
           <a:xfrm>
-            <a:off x="5723507" y="10997308"/>
-            <a:ext cx="3505201" cy="814803"/>
+            <a:off x="423746" y="3972039"/>
+            <a:ext cx="14942634" cy="4993776"/>
           </a:xfrm>
           <a:prstGeom prst="rect">
             <a:avLst/>
@@ -4187,7 +4213,7 @@
           <a:noFill/>
           <a:ln w="28575">
             <a:solidFill>
-              <a:schemeClr val="accent1"/>
+              <a:srgbClr val="FF0000"/>
             </a:solidFill>
           </a:ln>
         </p:spPr>
@@ -4212,20 +4238,16 @@
           <a:lstStyle/>
           <a:p>
             <a:pPr algn="ctr"/>
-            <a:endParaRPr lang="sv-SE">
-              <a:solidFill>
-                <a:srgbClr val="00B0F0"/>
-              </a:solidFill>
-            </a:endParaRPr>
-          </a:p>
-        </p:txBody>
-      </p:sp>
-      <p:sp>
-        <p:nvSpPr>
-          <p:cNvPr id="28" name="textruta 27">
+            <a:endParaRPr lang="sv-SE"/>
+          </a:p>
+        </p:txBody>
+      </p:sp>
+      <p:sp>
+        <p:nvSpPr>
+          <p:cNvPr id="36" name="textruta 35">
             <a:extLst>
               <a:ext uri="{FF2B5EF4-FFF2-40B4-BE49-F238E27FC236}">
-                <a16:creationId xmlns:a16="http://schemas.microsoft.com/office/drawing/2014/main" id="{1DE75AA9-D956-D242-B48C-BAC6595C184F}"/>
+                <a16:creationId xmlns:a16="http://schemas.microsoft.com/office/drawing/2014/main" id="{CC70E0F9-7025-E44E-9BFF-E1DF6E4A499D}"/>
               </a:ext>
             </a:extLst>
           </p:cNvPr>
@@ -4234,8 +4256,52 @@
         </p:nvSpPr>
         <p:spPr>
           <a:xfrm>
-            <a:off x="7920038" y="11155849"/>
-            <a:ext cx="1651379" cy="646331"/>
+            <a:off x="11339602" y="8331258"/>
+            <a:ext cx="1651379" cy="400110"/>
+          </a:xfrm>
+          <a:prstGeom prst="rect">
+            <a:avLst/>
+          </a:prstGeom>
+          <a:noFill/>
+        </p:spPr>
+        <p:txBody>
+          <a:bodyPr wrap="square" rtlCol="0">
+            <a:spAutoFit/>
+          </a:bodyPr>
+          <a:lstStyle/>
+          <a:p>
+            <a:r>
+              <a:rPr lang="sv-SE" sz="2000" dirty="0" err="1">
+                <a:solidFill>
+                  <a:srgbClr val="FF0000"/>
+                </a:solidFill>
+              </a:rPr>
+              <a:t>LuRow</a:t>
+            </a:r>
+            <a:endParaRPr lang="sv-SE" sz="2000" dirty="0">
+              <a:solidFill>
+                <a:srgbClr val="FF0000"/>
+              </a:solidFill>
+            </a:endParaRPr>
+          </a:p>
+        </p:txBody>
+      </p:sp>
+      <p:sp>
+        <p:nvSpPr>
+          <p:cNvPr id="37" name="textruta 36">
+            <a:extLst>
+              <a:ext uri="{FF2B5EF4-FFF2-40B4-BE49-F238E27FC236}">
+                <a16:creationId xmlns:a16="http://schemas.microsoft.com/office/drawing/2014/main" id="{FA8F41AB-4D2C-2142-A519-CC0A78B10E95}"/>
+              </a:ext>
+            </a:extLst>
+          </p:cNvPr>
+          <p:cNvSpPr txBox="1"/>
+          <p:nvPr/>
+        </p:nvSpPr>
+        <p:spPr>
+          <a:xfrm>
+            <a:off x="12990981" y="4374729"/>
+            <a:ext cx="3276679" cy="646331"/>
           </a:xfrm>
           <a:prstGeom prst="rect">
             <a:avLst/>
@@ -4254,24 +4320,53 @@
                   <a:schemeClr val="accent1"/>
                 </a:solidFill>
               </a:rPr>
-              <a:t>social</a:t>
-            </a:r>
-          </a:p>
-          <a:p>
+              <a:t>right-</a:t>
+            </a:r>
+            <a:r>
+              <a:rPr lang="sv-SE" dirty="0" err="1">
+                <a:solidFill>
+                  <a:schemeClr val="accent1"/>
+                </a:solidFill>
+              </a:rPr>
+              <a:t>column</a:t>
+            </a:r>
+            <a:r>
+              <a:rPr lang="sv-SE" dirty="0">
+                <a:solidFill>
+                  <a:schemeClr val="accent1"/>
+                </a:solidFill>
+              </a:rPr>
+              <a:t> </a:t>
+            </a:r>
+            <a:r>
+              <a:rPr lang="sv-SE" dirty="0" err="1">
+                <a:solidFill>
+                  <a:schemeClr val="accent1"/>
+                </a:solidFill>
+              </a:rPr>
+              <a:t>slot</a:t>
+            </a:r>
             <a:endParaRPr lang="sv-SE" dirty="0">
               <a:solidFill>
                 <a:schemeClr val="accent1"/>
               </a:solidFill>
             </a:endParaRPr>
           </a:p>
-        </p:txBody>
-      </p:sp>
-      <p:sp>
-        <p:nvSpPr>
-          <p:cNvPr id="29" name="Rektangel 28">
+          <a:p>
+            <a:endParaRPr lang="sv-SE" dirty="0">
+              <a:solidFill>
+                <a:schemeClr val="accent1"/>
+              </a:solidFill>
+            </a:endParaRPr>
+          </a:p>
+        </p:txBody>
+      </p:sp>
+      <p:sp>
+        <p:nvSpPr>
+          <p:cNvPr id="38" name="Rektangel 37">
             <a:extLst>
               <a:ext uri="{FF2B5EF4-FFF2-40B4-BE49-F238E27FC236}">
-                <a16:creationId xmlns:a16="http://schemas.microsoft.com/office/drawing/2014/main" id="{0FDDB090-A945-5246-8689-8BE882A94EEF}"/>
+                <a16:creationId xmlns:a16="http://schemas.microsoft.com/office/drawing/2014/main" id="{78B1090B-0800-564C-B5EA-4DB1655DE9E4}"/>
               </a:ext>
             </a:extLst>
           </p:cNvPr>
@@ -4280,8 +4375,8 @@
         </p:nvSpPr>
         <p:spPr>
           <a:xfrm>
-            <a:off x="4781812" y="4415453"/>
-            <a:ext cx="6821604" cy="3193080"/>
+            <a:off x="10114510" y="4029900"/>
+            <a:ext cx="5162661" cy="4166779"/>
           </a:xfrm>
           <a:prstGeom prst="rect">
             <a:avLst/>
@@ -4324,69 +4419,10 @@
       </p:sp>
       <p:sp>
         <p:nvSpPr>
-          <p:cNvPr id="30" name="textruta 29">
+          <p:cNvPr id="39" name="Rektangel 38">
             <a:extLst>
               <a:ext uri="{FF2B5EF4-FFF2-40B4-BE49-F238E27FC236}">
-                <a16:creationId xmlns:a16="http://schemas.microsoft.com/office/drawing/2014/main" id="{5CA90985-43AB-A445-8B15-F9F21B9B44F1}"/>
-              </a:ext>
-            </a:extLst>
-          </p:cNvPr>
-          <p:cNvSpPr txBox="1"/>
-          <p:nvPr/>
-        </p:nvSpPr>
-        <p:spPr>
-          <a:xfrm>
-            <a:off x="6384495" y="4523374"/>
-            <a:ext cx="3276679" cy="646331"/>
-          </a:xfrm>
-          <a:prstGeom prst="rect">
-            <a:avLst/>
-          </a:prstGeom>
-          <a:noFill/>
-        </p:spPr>
-        <p:txBody>
-          <a:bodyPr wrap="square" rtlCol="0">
-            <a:spAutoFit/>
-          </a:bodyPr>
-          <a:lstStyle/>
-          <a:p>
-            <a:r>
-              <a:rPr lang="sv-SE" dirty="0">
-                <a:solidFill>
-                  <a:schemeClr val="accent1"/>
-                </a:solidFill>
-              </a:rPr>
-              <a:t>default </a:t>
-            </a:r>
-            <a:r>
-              <a:rPr lang="sv-SE" dirty="0" err="1">
-                <a:solidFill>
-                  <a:schemeClr val="accent1"/>
-                </a:solidFill>
-              </a:rPr>
-              <a:t>slot</a:t>
-            </a:r>
-            <a:endParaRPr lang="sv-SE" dirty="0">
-              <a:solidFill>
-                <a:schemeClr val="accent1"/>
-              </a:solidFill>
-            </a:endParaRPr>
-          </a:p>
-          <a:p>
-            <a:endParaRPr lang="sv-SE" dirty="0">
-              <a:solidFill>
-                <a:schemeClr val="accent1"/>
-              </a:solidFill>
-            </a:endParaRPr>
-          </a:p>
-        </p:txBody>
-      </p:sp>
-      <p:sp>
-        <p:nvSpPr>
-          <p:cNvPr id="31" name="Rektangel 30">
-            <a:extLst>
-              <a:ext uri="{FF2B5EF4-FFF2-40B4-BE49-F238E27FC236}">
-                <a16:creationId xmlns:a16="http://schemas.microsoft.com/office/drawing/2014/main" id="{BB6E1F10-2781-8E4E-A39B-E195870A0F40}"/>
+                <a16:creationId xmlns:a16="http://schemas.microsoft.com/office/drawing/2014/main" id="{17233EC3-2974-0E4C-B031-BBE3D83BD79A}"/>
               </a:ext>
             </a:extLst>
           </p:cNvPr>
@@ -4395,8 +4431,8 @@
         </p:nvSpPr>
         <p:spPr>
           <a:xfrm>
-            <a:off x="5883301" y="7866732"/>
-            <a:ext cx="1741603" cy="494744"/>
+            <a:off x="13214195" y="9513922"/>
+            <a:ext cx="2571802" cy="1038860"/>
           </a:xfrm>
           <a:prstGeom prst="rect">
             <a:avLst/>
@@ -4404,7 +4440,7 @@
           <a:noFill/>
           <a:ln w="28575">
             <a:solidFill>
-              <a:schemeClr val="accent1"/>
+              <a:srgbClr val="FF0000"/>
             </a:solidFill>
           </a:ln>
         </p:spPr>
@@ -4429,20 +4465,23 @@
           <a:lstStyle/>
           <a:p>
             <a:pPr algn="ctr"/>
-            <a:endParaRPr lang="sv-SE">
-              <a:solidFill>
-                <a:srgbClr val="00B0F0"/>
-              </a:solidFill>
-            </a:endParaRPr>
-          </a:p>
-        </p:txBody>
-      </p:sp>
-      <p:sp>
-        <p:nvSpPr>
-          <p:cNvPr id="32" name="textruta 31">
+            <a:r>
+              <a:rPr lang="sv-SE"/>
+              <a:t>LuToTop</a:t>
+            </a:r>
+          </a:p>
+          <a:p>
+            <a:pPr algn="ctr"/>
+            <a:endParaRPr lang="sv-SE"/>
+          </a:p>
+        </p:txBody>
+      </p:sp>
+      <p:sp>
+        <p:nvSpPr>
+          <p:cNvPr id="40" name="textruta 39">
             <a:extLst>
               <a:ext uri="{FF2B5EF4-FFF2-40B4-BE49-F238E27FC236}">
-                <a16:creationId xmlns:a16="http://schemas.microsoft.com/office/drawing/2014/main" id="{67E51921-BC36-9143-A3EB-BAAE8E188D5A}"/>
+                <a16:creationId xmlns:a16="http://schemas.microsoft.com/office/drawing/2014/main" id="{3C00DD8C-E8FE-864B-9702-D9B7E9F314A4}"/>
               </a:ext>
             </a:extLst>
           </p:cNvPr>
@@ -4451,8 +4490,8 @@
         </p:nvSpPr>
         <p:spPr>
           <a:xfrm>
-            <a:off x="5939695" y="7758800"/>
-            <a:ext cx="1516544" cy="646331"/>
+            <a:off x="5040665" y="9746726"/>
+            <a:ext cx="2415573" cy="646331"/>
           </a:xfrm>
           <a:prstGeom prst="rect">
             <a:avLst/>
@@ -4471,7 +4510,7 @@
                   <a:schemeClr val="accent1"/>
                 </a:solidFill>
               </a:rPr>
-              <a:t>pageManager</a:t>
+              <a:t>pageManagerNotice</a:t>
             </a:r>
             <a:endParaRPr lang="sv-SE" dirty="0">
               <a:solidFill>
@@ -4490,10 +4529,10 @@
       </p:sp>
       <p:sp>
         <p:nvSpPr>
-          <p:cNvPr id="33" name="Rektangel 32">
+          <p:cNvPr id="42" name="Rektangel 41">
             <a:extLst>
               <a:ext uri="{FF2B5EF4-FFF2-40B4-BE49-F238E27FC236}">
-                <a16:creationId xmlns:a16="http://schemas.microsoft.com/office/drawing/2014/main" id="{74573ADC-8E09-954C-9BFD-153A42E84E0E}"/>
+                <a16:creationId xmlns:a16="http://schemas.microsoft.com/office/drawing/2014/main" id="{005F0B16-9B7F-D54D-B82D-1B29555569DF}"/>
               </a:ext>
             </a:extLst>
           </p:cNvPr>
@@ -4502,8 +4541,8 @@
         </p:nvSpPr>
         <p:spPr>
           <a:xfrm>
-            <a:off x="7761598" y="7858004"/>
-            <a:ext cx="1741603" cy="494745"/>
+            <a:off x="672255" y="9746725"/>
+            <a:ext cx="6783983" cy="436109"/>
           </a:xfrm>
           <a:prstGeom prst="rect">
             <a:avLst/>
@@ -4544,63 +4583,12 @@
           </a:p>
         </p:txBody>
       </p:sp>
-      <p:sp>
-        <p:nvSpPr>
-          <p:cNvPr id="34" name="textruta 33">
+      <p:pic>
+        <p:nvPicPr>
+          <p:cNvPr id="16" name="Bildobjekt 15">
             <a:extLst>
               <a:ext uri="{FF2B5EF4-FFF2-40B4-BE49-F238E27FC236}">
-                <a16:creationId xmlns:a16="http://schemas.microsoft.com/office/drawing/2014/main" id="{84F9CB2F-73B8-914F-BC19-CEBA68229E2B}"/>
-              </a:ext>
-            </a:extLst>
-          </p:cNvPr>
-          <p:cNvSpPr txBox="1"/>
-          <p:nvPr/>
-        </p:nvSpPr>
-        <p:spPr>
-          <a:xfrm>
-            <a:off x="7781665" y="7769058"/>
-            <a:ext cx="1516544" cy="646331"/>
-          </a:xfrm>
-          <a:prstGeom prst="rect">
-            <a:avLst/>
-          </a:prstGeom>
-          <a:noFill/>
-        </p:spPr>
-        <p:txBody>
-          <a:bodyPr wrap="square" rtlCol="0">
-            <a:spAutoFit/>
-          </a:bodyPr>
-          <a:lstStyle/>
-          <a:p>
-            <a:r>
-              <a:rPr lang="sv-SE" dirty="0" err="1">
-                <a:solidFill>
-                  <a:schemeClr val="accent1"/>
-                </a:solidFill>
-              </a:rPr>
-              <a:t>lastUpdated</a:t>
-            </a:r>
-            <a:endParaRPr lang="sv-SE" dirty="0">
-              <a:solidFill>
-                <a:schemeClr val="accent1"/>
-              </a:solidFill>
-            </a:endParaRPr>
-          </a:p>
-          <a:p>
-            <a:endParaRPr lang="sv-SE" dirty="0">
-              <a:solidFill>
-                <a:schemeClr val="accent1"/>
-              </a:solidFill>
-            </a:endParaRPr>
-          </a:p>
-        </p:txBody>
-      </p:sp>
-      <p:pic>
-        <p:nvPicPr>
-          <p:cNvPr id="2" name="Bildobjekt 1">
-            <a:extLst>
-              <a:ext uri="{FF2B5EF4-FFF2-40B4-BE49-F238E27FC236}">
-                <a16:creationId xmlns:a16="http://schemas.microsoft.com/office/drawing/2014/main" id="{4E6E7C3D-C909-ED4C-AC29-784ABE40D61D}"/>
+                <a16:creationId xmlns:a16="http://schemas.microsoft.com/office/drawing/2014/main" id="{DE1987FF-F191-D2F4-A2FF-6206E97F92B0}"/>
               </a:ext>
             </a:extLst>
           </p:cNvPr>
@@ -4617,8 +4605,8 @@
         </p:blipFill>
         <p:spPr>
           <a:xfrm>
-            <a:off x="11775374" y="4376310"/>
-            <a:ext cx="2750484" cy="2272139"/>
+            <a:off x="13395069" y="9790554"/>
+            <a:ext cx="2387600" cy="698500"/>
           </a:xfrm>
           <a:prstGeom prst="rect">
             <a:avLst/>
@@ -4627,62 +4615,10 @@
       </p:pic>
       <p:sp>
         <p:nvSpPr>
-          <p:cNvPr id="35" name="Rektangel 34">
+          <p:cNvPr id="22" name="textruta 21">
             <a:extLst>
               <a:ext uri="{FF2B5EF4-FFF2-40B4-BE49-F238E27FC236}">
-                <a16:creationId xmlns:a16="http://schemas.microsoft.com/office/drawing/2014/main" id="{EAF89F60-878A-9E4D-961F-C89D1B752D86}"/>
-              </a:ext>
-            </a:extLst>
-          </p:cNvPr>
-          <p:cNvSpPr/>
-          <p:nvPr/>
-        </p:nvSpPr>
-        <p:spPr>
-          <a:xfrm>
-            <a:off x="4663374" y="4247286"/>
-            <a:ext cx="9995601" cy="3517474"/>
-          </a:xfrm>
-          <a:prstGeom prst="rect">
-            <a:avLst/>
-          </a:prstGeom>
-          <a:noFill/>
-          <a:ln w="28575">
-            <a:solidFill>
-              <a:srgbClr val="FF0000"/>
-            </a:solidFill>
-          </a:ln>
-        </p:spPr>
-        <p:style>
-          <a:lnRef idx="2">
-            <a:schemeClr val="accent1">
-              <a:shade val="50000"/>
-            </a:schemeClr>
-          </a:lnRef>
-          <a:fillRef idx="1">
-            <a:schemeClr val="accent1"/>
-          </a:fillRef>
-          <a:effectRef idx="0">
-            <a:schemeClr val="accent1"/>
-          </a:effectRef>
-          <a:fontRef idx="minor">
-            <a:schemeClr val="lt1"/>
-          </a:fontRef>
-        </p:style>
-        <p:txBody>
-          <a:bodyPr rtlCol="0" anchor="ctr"/>
-          <a:lstStyle/>
-          <a:p>
-            <a:pPr algn="ctr"/>
-            <a:endParaRPr lang="sv-SE"/>
-          </a:p>
-        </p:txBody>
-      </p:sp>
-      <p:sp>
-        <p:nvSpPr>
-          <p:cNvPr id="36" name="textruta 35">
-            <a:extLst>
-              <a:ext uri="{FF2B5EF4-FFF2-40B4-BE49-F238E27FC236}">
-                <a16:creationId xmlns:a16="http://schemas.microsoft.com/office/drawing/2014/main" id="{CC70E0F9-7025-E44E-9BFF-E1DF6E4A499D}"/>
+                <a16:creationId xmlns:a16="http://schemas.microsoft.com/office/drawing/2014/main" id="{6CF7FA14-49D7-46CD-B9FC-0D910CE92AD2}"/>
               </a:ext>
             </a:extLst>
           </p:cNvPr>
@@ -4691,8 +4627,8 @@
         </p:nvSpPr>
         <p:spPr>
           <a:xfrm>
-            <a:off x="7906998" y="4154042"/>
-            <a:ext cx="1651379" cy="369332"/>
+            <a:off x="13851312" y="9495263"/>
+            <a:ext cx="1422590" cy="400110"/>
           </a:xfrm>
           <a:prstGeom prst="rect">
             <a:avLst/>
@@ -4700,351 +4636,20 @@
           <a:noFill/>
         </p:spPr>
         <p:txBody>
-          <a:bodyPr wrap="square" rtlCol="0">
+          <a:bodyPr wrap="square">
             <a:spAutoFit/>
           </a:bodyPr>
           <a:lstStyle/>
           <a:p>
             <a:r>
-              <a:rPr lang="sv-SE" dirty="0" err="1">
+              <a:rPr lang="sv-SE" sz="2000">
                 <a:solidFill>
                   <a:srgbClr val="FF0000"/>
                 </a:solidFill>
               </a:rPr>
-              <a:t>LuRow</a:t>
-            </a:r>
-            <a:endParaRPr lang="sv-SE" dirty="0">
-              <a:solidFill>
-                <a:srgbClr val="FF0000"/>
-              </a:solidFill>
-            </a:endParaRPr>
-          </a:p>
-        </p:txBody>
-      </p:sp>
-      <p:sp>
-        <p:nvSpPr>
-          <p:cNvPr id="37" name="textruta 36">
-            <a:extLst>
-              <a:ext uri="{FF2B5EF4-FFF2-40B4-BE49-F238E27FC236}">
-                <a16:creationId xmlns:a16="http://schemas.microsoft.com/office/drawing/2014/main" id="{FA8F41AB-4D2C-2142-A519-CC0A78B10E95}"/>
-              </a:ext>
-            </a:extLst>
-          </p:cNvPr>
-          <p:cNvSpPr txBox="1"/>
-          <p:nvPr/>
-        </p:nvSpPr>
-        <p:spPr>
-          <a:xfrm>
-            <a:off x="12660164" y="4523374"/>
-            <a:ext cx="3276679" cy="646331"/>
-          </a:xfrm>
-          <a:prstGeom prst="rect">
-            <a:avLst/>
-          </a:prstGeom>
-          <a:noFill/>
-        </p:spPr>
-        <p:txBody>
-          <a:bodyPr wrap="square" rtlCol="0">
-            <a:spAutoFit/>
-          </a:bodyPr>
-          <a:lstStyle/>
-          <a:p>
-            <a:r>
-              <a:rPr lang="sv-SE" dirty="0">
-                <a:solidFill>
-                  <a:schemeClr val="accent1"/>
-                </a:solidFill>
-              </a:rPr>
-              <a:t>right-</a:t>
-            </a:r>
-            <a:r>
-              <a:rPr lang="sv-SE" dirty="0" err="1">
-                <a:solidFill>
-                  <a:schemeClr val="accent1"/>
-                </a:solidFill>
-              </a:rPr>
-              <a:t>column</a:t>
-            </a:r>
-            <a:r>
-              <a:rPr lang="sv-SE" dirty="0">
-                <a:solidFill>
-                  <a:schemeClr val="accent1"/>
-                </a:solidFill>
-              </a:rPr>
-              <a:t> </a:t>
-            </a:r>
-            <a:r>
-              <a:rPr lang="sv-SE" dirty="0" err="1">
-                <a:solidFill>
-                  <a:schemeClr val="accent1"/>
-                </a:solidFill>
-              </a:rPr>
-              <a:t>slot</a:t>
-            </a:r>
-            <a:endParaRPr lang="sv-SE" dirty="0">
-              <a:solidFill>
-                <a:schemeClr val="accent1"/>
-              </a:solidFill>
-            </a:endParaRPr>
-          </a:p>
-          <a:p>
-            <a:endParaRPr lang="sv-SE" dirty="0">
-              <a:solidFill>
-                <a:schemeClr val="accent1"/>
-              </a:solidFill>
-            </a:endParaRPr>
-          </a:p>
-        </p:txBody>
-      </p:sp>
-      <p:sp>
-        <p:nvSpPr>
-          <p:cNvPr id="38" name="Rektangel 37">
-            <a:extLst>
-              <a:ext uri="{FF2B5EF4-FFF2-40B4-BE49-F238E27FC236}">
-                <a16:creationId xmlns:a16="http://schemas.microsoft.com/office/drawing/2014/main" id="{78B1090B-0800-564C-B5EA-4DB1655DE9E4}"/>
-              </a:ext>
-            </a:extLst>
-          </p:cNvPr>
-          <p:cNvSpPr/>
-          <p:nvPr/>
-        </p:nvSpPr>
-        <p:spPr>
-          <a:xfrm>
-            <a:off x="11719265" y="4386449"/>
-            <a:ext cx="2888254" cy="3222083"/>
-          </a:xfrm>
-          <a:prstGeom prst="rect">
-            <a:avLst/>
-          </a:prstGeom>
-          <a:noFill/>
-          <a:ln w="28575">
-            <a:solidFill>
-              <a:schemeClr val="accent1"/>
-            </a:solidFill>
-          </a:ln>
-        </p:spPr>
-        <p:style>
-          <a:lnRef idx="2">
-            <a:schemeClr val="accent1">
-              <a:shade val="50000"/>
-            </a:schemeClr>
-          </a:lnRef>
-          <a:fillRef idx="1">
-            <a:schemeClr val="accent1"/>
-          </a:fillRef>
-          <a:effectRef idx="0">
-            <a:schemeClr val="accent1"/>
-          </a:effectRef>
-          <a:fontRef idx="minor">
-            <a:schemeClr val="lt1"/>
-          </a:fontRef>
-        </p:style>
-        <p:txBody>
-          <a:bodyPr rtlCol="0" anchor="ctr"/>
-          <a:lstStyle/>
-          <a:p>
-            <a:pPr algn="ctr"/>
-            <a:endParaRPr lang="sv-SE">
-              <a:solidFill>
-                <a:srgbClr val="00B0F0"/>
-              </a:solidFill>
-            </a:endParaRPr>
-          </a:p>
-        </p:txBody>
-      </p:sp>
-      <p:pic>
-        <p:nvPicPr>
-          <p:cNvPr id="4" name="Bildobjekt 3">
-            <a:extLst>
-              <a:ext uri="{FF2B5EF4-FFF2-40B4-BE49-F238E27FC236}">
-                <a16:creationId xmlns:a16="http://schemas.microsoft.com/office/drawing/2014/main" id="{AB4847C6-44D4-3141-A8C5-845AF6702EF8}"/>
-              </a:ext>
-            </a:extLst>
-          </p:cNvPr>
-          <p:cNvPicPr>
-            <a:picLocks noChangeAspect="1"/>
-          </p:cNvPicPr>
-          <p:nvPr/>
-        </p:nvPicPr>
-        <p:blipFill>
-          <a:blip r:embed="rId4"/>
-          <a:stretch>
-            <a:fillRect/>
-          </a:stretch>
-        </p:blipFill>
-        <p:spPr>
-          <a:xfrm>
-            <a:off x="13990637" y="10556046"/>
-            <a:ext cx="1041400" cy="406400"/>
-          </a:xfrm>
-          <a:prstGeom prst="rect">
-            <a:avLst/>
-          </a:prstGeom>
-        </p:spPr>
-      </p:pic>
-      <p:sp>
-        <p:nvSpPr>
-          <p:cNvPr id="39" name="Rektangel 38">
-            <a:extLst>
-              <a:ext uri="{FF2B5EF4-FFF2-40B4-BE49-F238E27FC236}">
-                <a16:creationId xmlns:a16="http://schemas.microsoft.com/office/drawing/2014/main" id="{17233EC3-2974-0E4C-B031-BBE3D83BD79A}"/>
-              </a:ext>
-            </a:extLst>
-          </p:cNvPr>
-          <p:cNvSpPr/>
-          <p:nvPr/>
-        </p:nvSpPr>
-        <p:spPr>
-          <a:xfrm>
-            <a:off x="12898877" y="10182505"/>
-            <a:ext cx="2133160" cy="814803"/>
-          </a:xfrm>
-          <a:prstGeom prst="rect">
-            <a:avLst/>
-          </a:prstGeom>
-          <a:noFill/>
-          <a:ln w="28575">
-            <a:solidFill>
-              <a:srgbClr val="FF0000"/>
-            </a:solidFill>
-          </a:ln>
-        </p:spPr>
-        <p:style>
-          <a:lnRef idx="2">
-            <a:schemeClr val="accent1">
-              <a:shade val="50000"/>
-            </a:schemeClr>
-          </a:lnRef>
-          <a:fillRef idx="1">
-            <a:schemeClr val="accent1"/>
-          </a:fillRef>
-          <a:effectRef idx="0">
-            <a:schemeClr val="accent1"/>
-          </a:effectRef>
-          <a:fontRef idx="minor">
-            <a:schemeClr val="lt1"/>
-          </a:fontRef>
-        </p:style>
-        <p:txBody>
-          <a:bodyPr rtlCol="0" anchor="ctr"/>
-          <a:lstStyle/>
-          <a:p>
-            <a:pPr algn="ctr"/>
-            <a:r>
-              <a:rPr lang="sv-SE"/>
               <a:t>LuToTop</a:t>
             </a:r>
-          </a:p>
-          <a:p>
-            <a:pPr algn="ctr"/>
             <a:endParaRPr lang="sv-SE"/>
-          </a:p>
-        </p:txBody>
-      </p:sp>
-      <p:sp>
-        <p:nvSpPr>
-          <p:cNvPr id="40" name="textruta 39">
-            <a:extLst>
-              <a:ext uri="{FF2B5EF4-FFF2-40B4-BE49-F238E27FC236}">
-                <a16:creationId xmlns:a16="http://schemas.microsoft.com/office/drawing/2014/main" id="{3C00DD8C-E8FE-864B-9702-D9B7E9F314A4}"/>
-              </a:ext>
-            </a:extLst>
-          </p:cNvPr>
-          <p:cNvSpPr txBox="1"/>
-          <p:nvPr/>
-        </p:nvSpPr>
-        <p:spPr>
-          <a:xfrm>
-            <a:off x="4648500" y="8414504"/>
-            <a:ext cx="2415573" cy="646331"/>
-          </a:xfrm>
-          <a:prstGeom prst="rect">
-            <a:avLst/>
-          </a:prstGeom>
-          <a:noFill/>
-        </p:spPr>
-        <p:txBody>
-          <a:bodyPr wrap="square" rtlCol="0">
-            <a:spAutoFit/>
-          </a:bodyPr>
-          <a:lstStyle/>
-          <a:p>
-            <a:r>
-              <a:rPr lang="sv-SE" dirty="0" err="1">
-                <a:solidFill>
-                  <a:schemeClr val="accent1"/>
-                </a:solidFill>
-              </a:rPr>
-              <a:t>pageManagerNotice</a:t>
-            </a:r>
-            <a:endParaRPr lang="sv-SE" dirty="0">
-              <a:solidFill>
-                <a:schemeClr val="accent1"/>
-              </a:solidFill>
-            </a:endParaRPr>
-          </a:p>
-          <a:p>
-            <a:endParaRPr lang="sv-SE" dirty="0">
-              <a:solidFill>
-                <a:schemeClr val="accent1"/>
-              </a:solidFill>
-            </a:endParaRPr>
-          </a:p>
-        </p:txBody>
-      </p:sp>
-      <p:sp>
-        <p:nvSpPr>
-          <p:cNvPr id="42" name="Rektangel 41">
-            <a:extLst>
-              <a:ext uri="{FF2B5EF4-FFF2-40B4-BE49-F238E27FC236}">
-                <a16:creationId xmlns:a16="http://schemas.microsoft.com/office/drawing/2014/main" id="{005F0B16-9B7F-D54D-B82D-1B29555569DF}"/>
-              </a:ext>
-            </a:extLst>
-          </p:cNvPr>
-          <p:cNvSpPr/>
-          <p:nvPr/>
-        </p:nvSpPr>
-        <p:spPr>
-          <a:xfrm>
-            <a:off x="4683204" y="8296837"/>
-            <a:ext cx="2088906" cy="478784"/>
-          </a:xfrm>
-          <a:prstGeom prst="rect">
-            <a:avLst/>
-          </a:prstGeom>
-          <a:noFill/>
-          <a:ln w="28575">
-            <a:solidFill>
-              <a:schemeClr val="accent1"/>
-            </a:solidFill>
-          </a:ln>
-        </p:spPr>
-        <p:style>
-          <a:lnRef idx="2">
-            <a:schemeClr val="accent1">
-              <a:shade val="50000"/>
-            </a:schemeClr>
-          </a:lnRef>
-          <a:fillRef idx="1">
-            <a:schemeClr val="accent1"/>
-          </a:fillRef>
-          <a:effectRef idx="0">
-            <a:schemeClr val="accent1"/>
-          </a:effectRef>
-          <a:fontRef idx="minor">
-            <a:schemeClr val="lt1"/>
-          </a:fontRef>
-        </p:style>
-        <p:txBody>
-          <a:bodyPr rtlCol="0" anchor="ctr"/>
-          <a:lstStyle/>
-          <a:p>
-            <a:pPr algn="ctr"/>
-            <a:endParaRPr lang="sv-SE">
-              <a:solidFill>
-                <a:srgbClr val="00B0F0"/>
-              </a:solidFill>
-            </a:endParaRPr>
           </a:p>
         </p:txBody>
       </p:sp>

</xml_diff>